<commit_message>
ADG: 9장 보강 — 옵션 없는 대안 경로(MOUNTED Standby)
실습 주제 목록 9장 7번을 실측해 반영한다. 계획 미이행 항목은 0 개가 되었다.

- 본문에 9.8 "옵션이 없다면 — MOUNTED 로 두고 확인한다" 신설
  (요약 → 9.9, 퀴즈 → 9.10, 실습 개요 → 9.11)
- 실습 08 트랜스크립트 추가
- 객관식 [상-10] 교체, 서술형 [추가-19] 를 MOUNTED 사례까지 확장
- PPT 35 → 38장
- 9.7.1 이 @H2 로 잘못 달려 있던 것을 @H3 으로 수정

주요 실측
- Primary 의 V$DATAGUARD_STATS 는 0행이다.
  계획서의 "Primary 에서 V$DATAGUARD_STATS 로 확인" 은 성립하지 않는다
- MOUNTED 로 내려도 MRP0 은 APPLYING_LOG, 실시간 적용도 유지된다
- 사용자 표 조회는 ORA-01219, 고정 뷰는 그대로 조회된다
  → MOUNTED Standby 에서 두 지연을 그대로 잴 수 있다
- PDB 서비스가 사라져 ORA-12514 (리스너 부재의 ORA-12541 과 구별)
- Primary 쪽 표식은 DATABASE_MODE(OPEN_READ-ONLY ↔ MOUNTED-STANDBY)와
  RECOVERY_MODE 의 WITH QUERY 유무. APPLIED_SEQ# 는 닫은 뒤에도 올라간다
- Broker 의 Real Time Query 는 OFF 가 되지만 구성은 SUCCESS
- V$ARCHIVED_LOG 의 max(sequence#) 는 RESETLOGS 이전 번호를 집는다
  (실측 94, 그때 현재 시퀀스 12)

본문 29,946자, verify 21/21. 환경은 READ ONLY WITH APPLY 로 원복 확인.

Co-Authored-By: Claude Opus 5 (1M context) <noreply@anthropic.com>
</commit_message>
<xml_diff>
--- a/ADG/09장/9장_ActiveDataGuard_실시간조회와DML리다이렉션.pptx
+++ b/ADG/09장/9장_ActiveDataGuard_실시간조회와DML리다이렉션.pptx
@@ -40,6 +40,9 @@
     <p:sldId id="288" r:id="rId40"/>
     <p:sldId id="289" r:id="rId41"/>
     <p:sldId id="290" r:id="rId42"/>
+    <p:sldId id="291" r:id="rId43"/>
+    <p:sldId id="292" r:id="rId44"/>
+    <p:sldId id="293" r:id="rId45"/>
   </p:sldIdLst>
   <p:sldSz cx="12191695" cy="6858000" type="screen4x3"/>
   <p:notesSz cx="6858000" cy="9144000"/>
@@ -1587,6 +1590,146 @@
           <a:p>
             <a:r>
               <a:t>세 습관 모두 이 장의 실측에서 검증됐습니다. 첫 번째는 DML 리다이렉션과 지연 한도에서 각각 ORA-16397 과 ORA-03174 를 만난 경험입니다. 둘 다 일반 사용자로 바꾸자 바로 동작했습니다. 두 번째는 읽기 일관성 측정에서 SQL*Plus 의 암묵적 커밋 때문에 잘못된 결론에 이를 뻔한 경험입니다. 세 번째는 같은 상황에서도 오류 번호가 다르면 처리 경로가 다르다는 것입니다. 기술적으로 어려운 내용은 없지만 습관이 되어 있어야 급할 때 제대로 판단할 수 있습니다.</a:t>
+            </a:r>
+          </a:p>
+        </p:txBody>
+      </p:sp>
+      <p:sp>
+        <p:nvSpPr>
+          <p:cNvPr id="4" name="Slide Number Placeholder 3"/>
+          <p:cNvSpPr>
+            <a:spLocks noGrp="1"/>
+          </p:cNvSpPr>
+          <p:nvPr>
+            <p:ph type="sldNum" idx="5" sz="quarter"/>
+          </p:nvPr>
+        </p:nvSpPr>
+        <p:spPr/>
+      </p:sp>
+    </p:spTree>
+  </p:cSld>
+  <p:clrMapOvr>
+    <a:masterClrMapping/>
+  </p:clrMapOvr>
+</p:notes>
+</file>
+
+<file path=ppt/notesSlides/notesSlide24.xml><?xml version="1.0" encoding="utf-8"?>
+<p:notes xmlns:a="http://schemas.openxmlformats.org/drawingml/2006/main" xmlns:p="http://schemas.openxmlformats.org/presentationml/2006/main" xmlns:r="http://schemas.openxmlformats.org/officeDocument/2006/relationships">
+  <p:cSld>
+    <p:spTree>
+      <p:nvGrpSpPr>
+        <p:cNvPr id="1" name=""/>
+        <p:cNvGrpSpPr/>
+        <p:nvPr/>
+      </p:nvGrpSpPr>
+      <p:grpSpPr>
+        <a:xfrm>
+          <a:off x="0" y="0"/>
+          <a:ext cx="0" cy="0"/>
+          <a:chOff x="0" y="0"/>
+          <a:chExt cx="0" cy="0"/>
+        </a:xfrm>
+      </p:grpSpPr>
+      <p:sp>
+        <p:nvSpPr>
+          <p:cNvPr id="2" name="Slide Image Placeholder 1"/>
+          <p:cNvSpPr>
+            <a:spLocks noGrp="1"/>
+          </p:cNvSpPr>
+          <p:nvPr>
+            <p:ph type="sldImg" idx="2"/>
+          </p:nvPr>
+        </p:nvSpPr>
+        <p:spPr/>
+      </p:sp>
+      <p:sp>
+        <p:nvSpPr>
+          <p:cNvPr id="3" name="Notes Placeholder 2"/>
+          <p:cNvSpPr>
+            <a:spLocks noGrp="1"/>
+          </p:cNvSpPr>
+          <p:nvPr>
+            <p:ph type="body" idx="3" sz="quarter"/>
+          </p:nvPr>
+        </p:nvSpPr>
+        <p:spPr/>
+        <p:txBody>
+          <a:bodyPr/>
+          <a:lstStyle/>
+          <a:p>
+            <a:r>
+              <a:t>재해 복구 능력은 조금도 줄지 않는다. USING CURRENT LOGFILE 도 그대로 쓸 수 있어 실시간 적용이며, 줄어드는 것은 조회뿐이다. ORA-01219 는 열려 있지 않다는 뜻이고 ORA-16000 은 읽기 전용이라 쓸 수 없다는 뜻이다. 오류 번호가 상태를 가른다. 고정 뷰는 조회되므로 Standby 에 SYSDBA 로 붙기만 하면 두 지연을 그대로 잴 수 있다. PDB 서비스는 사라져 그 서비스로 접속하면 ORA-12514 다. 리스너는 살아 있고 등록된 서비스만 사라진 것이다.</a:t>
+            </a:r>
+          </a:p>
+        </p:txBody>
+      </p:sp>
+      <p:sp>
+        <p:nvSpPr>
+          <p:cNvPr id="4" name="Slide Number Placeholder 3"/>
+          <p:cNvSpPr>
+            <a:spLocks noGrp="1"/>
+          </p:cNvSpPr>
+          <p:nvPr>
+            <p:ph type="sldNum" idx="5" sz="quarter"/>
+          </p:nvPr>
+        </p:nvSpPr>
+        <p:spPr/>
+      </p:sp>
+    </p:spTree>
+  </p:cSld>
+  <p:clrMapOvr>
+    <a:masterClrMapping/>
+  </p:clrMapOvr>
+</p:notes>
+</file>
+
+<file path=ppt/notesSlides/notesSlide25.xml><?xml version="1.0" encoding="utf-8"?>
+<p:notes xmlns:a="http://schemas.openxmlformats.org/drawingml/2006/main" xmlns:p="http://schemas.openxmlformats.org/presentationml/2006/main" xmlns:r="http://schemas.openxmlformats.org/officeDocument/2006/relationships">
+  <p:cSld>
+    <p:spTree>
+      <p:nvGrpSpPr>
+        <p:cNvPr id="1" name=""/>
+        <p:cNvGrpSpPr/>
+        <p:nvPr/>
+      </p:nvGrpSpPr>
+      <p:grpSpPr>
+        <a:xfrm>
+          <a:off x="0" y="0"/>
+          <a:ext cx="0" cy="0"/>
+          <a:chOff x="0" y="0"/>
+          <a:chExt cx="0" cy="0"/>
+        </a:xfrm>
+      </p:grpSpPr>
+      <p:sp>
+        <p:nvSpPr>
+          <p:cNvPr id="2" name="Slide Image Placeholder 1"/>
+          <p:cNvSpPr>
+            <a:spLocks noGrp="1"/>
+          </p:cNvSpPr>
+          <p:nvPr>
+            <p:ph type="sldImg" idx="2"/>
+          </p:nvPr>
+        </p:nvSpPr>
+        <p:spPr/>
+      </p:sp>
+      <p:sp>
+        <p:nvSpPr>
+          <p:cNvPr id="3" name="Notes Placeholder 2"/>
+          <p:cNvSpPr>
+            <a:spLocks noGrp="1"/>
+          </p:cNvSpPr>
+          <p:nvPr>
+            <p:ph type="body" idx="3" sz="quarter"/>
+          </p:nvPr>
+        </p:nvSpPr>
+        <p:spPr/>
+        <p:txBody>
+          <a:bodyPr/>
+          <a:lstStyle/>
+          <a:p>
+            <a:r>
+              <a:t>9.2.1 에서 정리한 표식 둘에 하나가 더 붙는 셈이고 이것은 Primary 에서 보이는 표식이다. WITH QUERY 가 있으면 그 Standby 는 열려 있고 곧 옵션을 쓰고 있다는 뜻이다. ARCHIVED_SEQ# 와 APPLIED_SEQ# 의 차이가 밀린 양이다. Broker 의 Real Time Query 도 ON 에서 OFF 로 바뀌지만 구성 상태는 양쪽 모두 SUCCESS 다. 닫는 것은 장애가 아니다. V$ARCHIVED_LOG 의 최댓값을 쓰면 RESETLOGS 이전 인큐네이션의 번호를 집는다. 실측에서 94 가 나왔는데 그때 현재 시퀀스는 12 였다.</a:t>
             </a:r>
           </a:p>
         </p:txBody>
@@ -7930,6 +8073,22 @@
               <a:t>•  `V$STANDBY_EVENT_HISTOGRAM` 으로 지연의 분포를 읽는다.</a:t>
             </a:r>
           </a:p>
+          <a:p>
+            <a:pPr algn="l">
+              <a:spcAft>
+                <a:spcPts val="1000"/>
+              </a:spcAft>
+            </a:pPr>
+            <a:r>
+              <a:rPr sz="1600" b="0">
+                <a:solidFill>
+                  <a:srgbClr val="222222"/>
+                </a:solidFill>
+                <a:latin typeface="맑은 고딕"/>
+              </a:rPr>
+              <a:t>•  옵션 없이 운영할 때 MOUNTED 로 두고 동기화를 확인하는 방법을 제시한다.</a:t>
+            </a:r>
+          </a:p>
         </p:txBody>
       </p:sp>
     </p:spTree>
@@ -10460,6 +10619,22 @@
               <a:t>•  9.7  지연의 분포 읽기</a:t>
             </a:r>
           </a:p>
+          <a:p>
+            <a:pPr algn="l">
+              <a:spcAft>
+                <a:spcPts val="1000"/>
+              </a:spcAft>
+            </a:pPr>
+            <a:r>
+              <a:rPr sz="1600" b="0">
+                <a:solidFill>
+                  <a:srgbClr val="222222"/>
+                </a:solidFill>
+                <a:latin typeface="맑은 고딕"/>
+              </a:rPr>
+              <a:t>•  9.8  옵션이 없다면 — MOUNTED 로 두고 확인한다</a:t>
+            </a:r>
+          </a:p>
         </p:txBody>
       </p:sp>
     </p:spTree>
@@ -11154,7 +11329,7 @@
         <p:spPr>
           <a:xfrm>
             <a:off x="0" y="0"/>
-            <a:ext cx="12191695" cy="1005840"/>
+            <a:ext cx="12191695" cy="6858000"/>
           </a:xfrm>
           <a:prstGeom prst="rect">
             <a:avLst/>
@@ -11197,8 +11372,8 @@
         </p:nvSpPr>
         <p:spPr>
           <a:xfrm>
-            <a:off x="548640" y="91440"/>
-            <a:ext cx="10972800" cy="777240"/>
+            <a:off x="822960" y="2011680"/>
+            <a:ext cx="10515600" cy="1097280"/>
           </a:xfrm>
           <a:prstGeom prst="rect">
             <a:avLst/>
@@ -11217,13 +11392,13 @@
               </a:spcAft>
             </a:pPr>
             <a:r>
-              <a:rPr sz="2600" b="1">
+              <a:rPr sz="4000" b="1">
                 <a:solidFill>
                   <a:srgbClr val="FFFFFF"/>
                 </a:solidFill>
                 <a:latin typeface="맑은 고딕"/>
               </a:rPr>
-              <a:t>퀴즈 (Quiz)</a:t>
+              <a:t>9.8</a:t>
             </a:r>
           </a:p>
         </p:txBody>
@@ -11236,8 +11411,8 @@
         </p:nvSpPr>
         <p:spPr>
           <a:xfrm>
-            <a:off x="640080" y="1371600"/>
-            <a:ext cx="10881360" cy="5120640"/>
+            <a:off x="822960" y="3017520"/>
+            <a:ext cx="10515600" cy="914400"/>
           </a:xfrm>
           <a:prstGeom prst="rect">
             <a:avLst/>
@@ -11252,97 +11427,116 @@
           <a:p>
             <a:pPr algn="l">
               <a:spcAft>
-                <a:spcPts val="1000"/>
+                <a:spcPts val="600"/>
+              </a:spcAft>
+            </a:pPr>
+            <a:r>
+              <a:rPr sz="2800" b="1">
+                <a:solidFill>
+                  <a:srgbClr val="FFFFFF"/>
+                </a:solidFill>
+                <a:latin typeface="맑은 고딕"/>
+              </a:rPr>
+              <a:t>옵션이 없다면</a:t>
+            </a:r>
+          </a:p>
+        </p:txBody>
+      </p:sp>
+      <p:sp>
+        <p:nvSpPr>
+          <p:cNvPr id="5" name="Rectangle 4"/>
+          <p:cNvSpPr/>
+          <p:nvPr/>
+        </p:nvSpPr>
+        <p:spPr>
+          <a:xfrm>
+            <a:off x="822960" y="4114800"/>
+            <a:ext cx="5486400" cy="54864"/>
+          </a:xfrm>
+          <a:prstGeom prst="rect">
+            <a:avLst/>
+          </a:prstGeom>
+          <a:solidFill>
+            <a:srgbClr val="FFFFFF"/>
+          </a:solidFill>
+          <a:ln>
+            <a:noFill/>
+          </a:ln>
+          <a:effectLst/>
+        </p:spPr>
+        <p:style>
+          <a:lnRef idx="1">
+            <a:schemeClr val="accent1"/>
+          </a:lnRef>
+          <a:fillRef idx="3">
+            <a:schemeClr val="accent1"/>
+          </a:fillRef>
+          <a:effectRef idx="2">
+            <a:schemeClr val="accent1"/>
+          </a:effectRef>
+          <a:fontRef idx="minor">
+            <a:schemeClr val="lt1"/>
+          </a:fontRef>
+        </p:style>
+        <p:txBody>
+          <a:bodyPr rtlCol="0" anchor="ctr"/>
+          <a:lstStyle/>
+          <a:p>
+            <a:pPr algn="ctr"/>
+          </a:p>
+        </p:txBody>
+      </p:sp>
+      <p:sp>
+        <p:nvSpPr>
+          <p:cNvPr id="6" name="TextBox 5"/>
+          <p:cNvSpPr txBox="1"/>
+          <p:nvPr/>
+        </p:nvSpPr>
+        <p:spPr>
+          <a:xfrm>
+            <a:off x="822960" y="4297680"/>
+            <a:ext cx="10058400" cy="2011680"/>
+          </a:xfrm>
+          <a:prstGeom prst="rect">
+            <a:avLst/>
+          </a:prstGeom>
+          <a:noFill/>
+        </p:spPr>
+        <p:txBody>
+          <a:bodyPr wrap="square">
+            <a:spAutoFit/>
+          </a:bodyPr>
+          <a:lstStyle/>
+          <a:p>
+            <a:pPr algn="l">
+              <a:spcAft>
+                <a:spcPts val="800"/>
               </a:spcAft>
             </a:pPr>
             <a:r>
               <a:rPr sz="1600" b="0">
                 <a:solidFill>
-                  <a:srgbClr val="222222"/>
-                </a:solidFill>
-                <a:latin typeface="맑은 고딕"/>
-              </a:rPr>
-              <a:t>•  Q1. Standby 에서 커밋되지 않은 데이터가 보이지 않는 이유를 리두·UNDO 적용과 연결해 설명하라.</a:t>
-            </a:r>
-          </a:p>
-          <a:p>
-            <a:pPr algn="l">
-              <a:spcAft>
-                <a:spcPts val="1000"/>
+                  <a:srgbClr val="FFFFFF"/>
+                </a:solidFill>
+                <a:latin typeface="맑은 고딕"/>
+              </a:rPr>
+              <a:t>•  MOUNTED 로 두면 적용만 남는다</a:t>
+            </a:r>
+          </a:p>
+          <a:p>
+            <a:pPr algn="l">
+              <a:spcAft>
+                <a:spcPts val="800"/>
               </a:spcAft>
             </a:pPr>
             <a:r>
               <a:rPr sz="1600" b="0">
                 <a:solidFill>
-                  <a:srgbClr val="222222"/>
-                </a:solidFill>
-                <a:latin typeface="맑은 고딕"/>
-              </a:rPr>
-              <a:t>•  Q2. 첫 측정이 잘못된 결론을 낼 뻔한 원인은 무엇이며, 어떻게 바로잡았는가?</a:t>
-            </a:r>
-          </a:p>
-          <a:p>
-            <a:pPr algn="l">
-              <a:spcAft>
-                <a:spcPts val="1000"/>
-              </a:spcAft>
-            </a:pPr>
-            <a:r>
-              <a:rPr sz="1600" b="0">
-                <a:solidFill>
-                  <a:srgbClr val="222222"/>
-                </a:solidFill>
-                <a:latin typeface="맑은 고딕"/>
-              </a:rPr>
-              <a:t>•  Q3. Standby 에서 되는 작업과 안 되는 작업을 가르는 기준은 무엇인가?</a:t>
-            </a:r>
-          </a:p>
-          <a:p>
-            <a:pPr algn="l">
-              <a:spcAft>
-                <a:spcPts val="1000"/>
-              </a:spcAft>
-            </a:pPr>
-            <a:r>
-              <a:rPr sz="1600" b="0">
-                <a:solidFill>
-                  <a:srgbClr val="222222"/>
-                </a:solidFill>
-                <a:latin typeface="맑은 고딕"/>
-              </a:rPr>
-              <a:t>•  Q4. Standby 에서 얻은 시퀀스 값이 Primary 와 연속되지 않는 이유와 실무적 함의는?</a:t>
-            </a:r>
-          </a:p>
-          <a:p>
-            <a:pPr algn="l">
-              <a:spcAft>
-                <a:spcPts val="1000"/>
-              </a:spcAft>
-            </a:pPr>
-            <a:r>
-              <a:rPr sz="1600" b="0">
-                <a:solidFill>
-                  <a:srgbClr val="222222"/>
-                </a:solidFill>
-                <a:latin typeface="맑은 고딕"/>
-              </a:rPr>
-              <a:t>•  Q5. DML 리다이렉션이 `SYS` 로 실패하는 이유와, 그것이 기능 검증에 주는 교훈은?</a:t>
-            </a:r>
-          </a:p>
-          <a:p>
-            <a:pPr algn="l">
-              <a:spcAft>
-                <a:spcPts val="1000"/>
-              </a:spcAft>
-            </a:pPr>
-            <a:r>
-              <a:rPr sz="1600" b="0">
-                <a:solidFill>
-                  <a:srgbClr val="222222"/>
-                </a:solidFill>
-                <a:latin typeface="맑은 고딕"/>
-              </a:rPr>
-              <a:t>•  Q6. ASYNC 구성에서 `SYNC WITH PRIMARY` 가 거부되는 이유를 보호 모드와 연결해 설명하라.</a:t>
+                  <a:srgbClr val="FFFFFF"/>
+                </a:solidFill>
+                <a:latin typeface="맑은 고딕"/>
+              </a:rPr>
+              <a:t>•  Primary 에서 읽는 두 열</a:t>
             </a:r>
           </a:p>
         </p:txBody>
@@ -11443,7 +11637,7 @@
                 </a:solidFill>
                 <a:latin typeface="맑은 고딕"/>
               </a:rPr>
-              <a:t>요약 (Summary)</a:t>
+              <a:t>닫아도 적용은 돈다</a:t>
             </a:r>
           </a:p>
         </p:txBody>
@@ -11456,8 +11650,8 @@
         </p:nvSpPr>
         <p:spPr>
           <a:xfrm>
-            <a:off x="640080" y="1371600"/>
-            <a:ext cx="10881360" cy="5120640"/>
+            <a:off x="640080" y="1078992"/>
+            <a:ext cx="10881360" cy="457200"/>
           </a:xfrm>
           <a:prstGeom prst="rect">
             <a:avLst/>
@@ -11472,17 +11666,56 @@
           <a:p>
             <a:pPr algn="l">
               <a:spcAft>
+                <a:spcPts val="600"/>
+              </a:spcAft>
+            </a:pPr>
+            <a:r>
+              <a:rPr sz="1500" b="0">
+                <a:solidFill>
+                  <a:srgbClr val="5A6672"/>
+                </a:solidFill>
+                <a:latin typeface="맑은 고딕"/>
+              </a:rPr>
+              <a:t>MOUNTED 의 실측</a:t>
+            </a:r>
+          </a:p>
+        </p:txBody>
+      </p:sp>
+      <p:sp>
+        <p:nvSpPr>
+          <p:cNvPr id="5" name="TextBox 4"/>
+          <p:cNvSpPr txBox="1"/>
+          <p:nvPr/>
+        </p:nvSpPr>
+        <p:spPr>
+          <a:xfrm>
+            <a:off x="640080" y="1737360"/>
+            <a:ext cx="10881360" cy="4754880"/>
+          </a:xfrm>
+          <a:prstGeom prst="rect">
+            <a:avLst/>
+          </a:prstGeom>
+          <a:noFill/>
+        </p:spPr>
+        <p:txBody>
+          <a:bodyPr wrap="square">
+            <a:spAutoFit/>
+          </a:bodyPr>
+          <a:lstStyle/>
+          <a:p>
+            <a:pPr algn="l">
+              <a:spcAft>
                 <a:spcPts val="1000"/>
               </a:spcAft>
             </a:pPr>
             <a:r>
-              <a:rPr sz="1600" b="0">
+              <a:rPr sz="1700" b="0">
                 <a:solidFill>
                   <a:srgbClr val="222222"/>
                 </a:solidFill>
                 <a:latin typeface="맑은 고딕"/>
               </a:rPr>
-              <a:t>•  ADG 의 표식은 `OPEN_MODE = READ ONLY WITH APPLY` 와 `RECOVERY_MODE = MANAGED REAL TIME APPLY` 두 가지다.</a:t>
+              <a:t>•  `OPEN_MODE` **MOUNTED**, `MRP0` 은 `APPLYING_LOG` 그대로</a:t>
             </a:r>
           </a:p>
           <a:p>
@@ -11492,13 +11725,13 @@
               </a:spcAft>
             </a:pPr>
             <a:r>
-              <a:rPr sz="1600" b="0">
+              <a:rPr sz="1700" b="0">
                 <a:solidFill>
                   <a:srgbClr val="222222"/>
                 </a:solidFill>
                 <a:latin typeface="맑은 고딕"/>
               </a:rPr>
-              <a:t>•  기능 사용 통계는 `CDB_` 뷰의 CON_ID 3 에만 있고 `DETECTED_USAGES` 는 0이었다. 라이선스 근거로는 부족하다.</a:t>
+              <a:t>•  사용자 표 조회 → **`ORA-01219`** (9.4 의 `ORA-16000` 과 다르다)</a:t>
             </a:r>
           </a:p>
           <a:p>
@@ -11508,13 +11741,13 @@
               </a:spcAft>
             </a:pPr>
             <a:r>
-              <a:rPr sz="1600" b="0">
+              <a:rPr sz="1700" b="0">
                 <a:solidFill>
                   <a:srgbClr val="222222"/>
                 </a:solidFill>
                 <a:latin typeface="맑은 고딕"/>
               </a:rPr>
-              <a:t>•  MOUNTED 로만 두면 ADG 옵션이 필요 없다. 여는 순간부터 옵션의 영역이다.</a:t>
+              <a:t>•  메시지의 뒷부분 — **"fixed tables or views only"**</a:t>
             </a:r>
           </a:p>
           <a:p>
@@ -11524,269 +11757,13 @@
               </a:spcAft>
             </a:pPr>
             <a:r>
-              <a:rPr sz="1600" b="0">
+              <a:rPr sz="1700" b="0">
                 <a:solidFill>
                   <a:srgbClr val="222222"/>
                 </a:solidFill>
                 <a:latin typeface="맑은 고딕"/>
               </a:rPr>
-              <a:t>•  Standby 조회는 **커밋된 데이터만** 보여 준다. 리두와 함께 UNDO 도 적용되기 때문이다.</a:t>
-            </a:r>
-          </a:p>
-          <a:p>
-            <a:pPr algn="l">
-              <a:spcAft>
-                <a:spcPts val="1000"/>
-              </a:spcAft>
-            </a:pPr>
-            <a:r>
-              <a:rPr sz="1600" b="0">
-                <a:solidFill>
-                  <a:srgbClr val="222222"/>
-                </a:solidFill>
-                <a:latin typeface="맑은 고딕"/>
-              </a:rPr>
-              <a:t>•  SQL*Plus 는 `EXIT` 시 암묵적으로 커밋한다. 이 때문에 첫 측정이 잘못된 결론을 낼 뻔했다.</a:t>
-            </a:r>
-          </a:p>
-          <a:p>
-            <a:pPr algn="l">
-              <a:spcAft>
-                <a:spcPts val="1000"/>
-              </a:spcAft>
-            </a:pPr>
-            <a:r>
-              <a:rPr sz="1600" b="0">
-                <a:solidFill>
-                  <a:srgbClr val="222222"/>
-                </a:solidFill>
-                <a:latin typeface="맑은 고딕"/>
-              </a:rPr>
-              <a:t>•  쓰기는 모두 **ORA-16000** 이다. `INSERT`·`UPDATE`·DDL 이 같은 오류다.</a:t>
-            </a:r>
-          </a:p>
-          <a:p>
-            <a:pPr algn="l">
-              <a:spcAft>
-                <a:spcPts val="1000"/>
-              </a:spcAft>
-            </a:pPr>
-            <a:r>
-              <a:rPr sz="1600" b="0">
-                <a:solidFill>
-                  <a:srgbClr val="222222"/>
-                </a:solidFill>
-                <a:latin typeface="맑은 고딕"/>
-              </a:rPr>
-              <a:t>•  정렬은 된다. 실측 7만 행 정렬에 TEMP 3MB 씩 사용됐다. 보고서 조회를 옮기는 근거다.</a:t>
-            </a:r>
-          </a:p>
-          <a:p>
-            <a:pPr algn="l">
-              <a:spcAft>
-                <a:spcPts val="1000"/>
-              </a:spcAft>
-            </a:pPr>
-            <a:r>
-              <a:rPr sz="1600" b="0">
-                <a:solidFill>
-                  <a:srgbClr val="222222"/>
-                </a:solidFill>
-                <a:latin typeface="맑은 고딕"/>
-              </a:rPr>
-              <a:t>•  `EXPLAIN PLAN` 과 GTT `INSERT` 도 된다. 데이터가 임시 테이블스페이스에 있기 때문이다.</a:t>
-            </a:r>
-          </a:p>
-          <a:p>
-            <a:pPr algn="l">
-              <a:spcAft>
-                <a:spcPts val="1000"/>
-              </a:spcAft>
-            </a:pPr>
-            <a:r>
-              <a:rPr sz="1600" b="0">
-                <a:solidFill>
-                  <a:srgbClr val="222222"/>
-                </a:solidFill>
-                <a:latin typeface="맑은 고딕"/>
-              </a:rPr>
-              <a:t>•  시퀀스도 되지만 **값이 뛴다.** Primary 에서 1이었던 시퀀스가 Standby 에서 21을 돌려주었다.</a:t>
-            </a:r>
-          </a:p>
-          <a:p>
-            <a:pPr algn="l">
-              <a:spcAft>
-                <a:spcPts val="1000"/>
-              </a:spcAft>
-            </a:pPr>
-            <a:r>
-              <a:rPr sz="1600" b="0">
-                <a:solidFill>
-                  <a:srgbClr val="222222"/>
-                </a:solidFill>
-                <a:latin typeface="맑은 고딕"/>
-              </a:rPr>
-              <a:t>•  통계 수집은 ORA-16000, AWR 은 전용 오류 **ORA-13516**. `V$` 뷰 조회는 자유롭다.</a:t>
-            </a:r>
-          </a:p>
-          <a:p>
-            <a:pPr algn="l">
-              <a:spcAft>
-                <a:spcPts val="1000"/>
-              </a:spcAft>
-            </a:pPr>
-            <a:r>
-              <a:rPr sz="1600" b="0">
-                <a:solidFill>
-                  <a:srgbClr val="222222"/>
-                </a:solidFill>
-                <a:latin typeface="맑은 고딕"/>
-              </a:rPr>
-              <a:t>•  경계를 가르는 기준은 **영구 데이터 파일이나 딕셔너리를 바꾸는가** 하나다.</a:t>
-            </a:r>
-          </a:p>
-          <a:p>
-            <a:pPr algn="l">
-              <a:spcAft>
-                <a:spcPts val="1000"/>
-              </a:spcAft>
-            </a:pPr>
-            <a:r>
-              <a:rPr sz="1600" b="0">
-                <a:solidFill>
-                  <a:srgbClr val="222222"/>
-                </a:solidFill>
-                <a:latin typeface="맑은 고딕"/>
-              </a:rPr>
-              <a:t>•  DML 리다이렉션은 일반 사용자로 `INSERT`·`UPDATE`·`DELETE` 가 모두 성공하며 Primary 에 반영된다.</a:t>
-            </a:r>
-          </a:p>
-          <a:p>
-            <a:pPr algn="l">
-              <a:spcAft>
-                <a:spcPts val="1000"/>
-              </a:spcAft>
-            </a:pPr>
-            <a:r>
-              <a:rPr sz="1600" b="0">
-                <a:solidFill>
-                  <a:srgbClr val="222222"/>
-                </a:solidFill>
-                <a:latin typeface="맑은 고딕"/>
-              </a:rPr>
-              <a:t>•  **`SYS` 로는 ORA-16397 로 실패한다.** 관리자 계정으로 시험하면 기능이 없다고 오판하기 쉽다.</a:t>
-            </a:r>
-          </a:p>
-          <a:p>
-            <a:pPr algn="l">
-              <a:spcAft>
-                <a:spcPts val="1000"/>
-              </a:spcAft>
-            </a:pPr>
-            <a:r>
-              <a:rPr sz="1600" b="0">
-                <a:solidFill>
-                  <a:srgbClr val="222222"/>
-                </a:solidFill>
-                <a:latin typeface="맑은 고딕"/>
-              </a:rPr>
-              <a:t>•  DDL 은 대상이 아니다. ORA-16000 이 나며, 오류 번호가 처리 경로를 알려 준다.</a:t>
-            </a:r>
-          </a:p>
-          <a:p>
-            <a:pPr algn="l">
-              <a:spcAft>
-                <a:spcPts val="1000"/>
-              </a:spcAft>
-            </a:pPr>
-            <a:r>
-              <a:rPr sz="1600" b="0">
-                <a:solidFill>
-                  <a:srgbClr val="222222"/>
-                </a:solidFill>
-                <a:latin typeface="맑은 고딕"/>
-              </a:rPr>
-              <a:t>•  리다이렉션의 가치는 부하 분산이 아니라 **접속 단순화**다. 실행은 Primary 에서 일어난다.</a:t>
-            </a:r>
-          </a:p>
-          <a:p>
-            <a:pPr algn="l">
-              <a:spcAft>
-                <a:spcPts val="1000"/>
-              </a:spcAft>
-            </a:pPr>
-            <a:r>
-              <a:rPr sz="1600" b="0">
-                <a:solidFill>
-                  <a:srgbClr val="222222"/>
-                </a:solidFill>
-                <a:latin typeface="맑은 고딕"/>
-              </a:rPr>
-              <a:t>•  `STANDBY_MAX_DATA_DELAY` 초과 시 **ORA-03172**. ASYNC 에서 0은 항상 위반된다.</a:t>
-            </a:r>
-          </a:p>
-          <a:p>
-            <a:pPr algn="l">
-              <a:spcAft>
-                <a:spcPts val="1000"/>
-              </a:spcAft>
-            </a:pPr>
-            <a:r>
-              <a:rPr sz="1600" b="0">
-                <a:solidFill>
-                  <a:srgbClr val="222222"/>
-                </a:solidFill>
-                <a:latin typeface="맑은 고딕"/>
-              </a:rPr>
-              <a:t>•  **`SYS` 세션에는 적용되지 않는다 — ORA-03174.** ADG 세션 기능은 일반 사용자를 전제로 한다.</a:t>
-            </a:r>
-          </a:p>
-          <a:p>
-            <a:pPr algn="l">
-              <a:spcAft>
-                <a:spcPts val="1000"/>
-              </a:spcAft>
-            </a:pPr>
-            <a:r>
-              <a:rPr sz="1600" b="0">
-                <a:solidFill>
-                  <a:srgbClr val="222222"/>
-                </a:solidFill>
-                <a:latin typeface="맑은 고딕"/>
-              </a:rPr>
-              <a:t>•  `SYNC WITH PRIMARY` 는 동기 전송이 전제다. ASYNC 에서는 **ORA-03173**.</a:t>
-            </a:r>
-          </a:p>
-          <a:p>
-            <a:pPr algn="l">
-              <a:spcAft>
-                <a:spcPts val="1000"/>
-              </a:spcAft>
-            </a:pPr>
-            <a:r>
-              <a:rPr sz="1600" b="0">
-                <a:solidFill>
-                  <a:srgbClr val="222222"/>
-                </a:solidFill>
-                <a:latin typeface="맑은 고딕"/>
-              </a:rPr>
-              <a:t>•  보호 모드는 8장에서 복구 가능성을, 9장에서 조회 신선도 보장을 결정했다.</a:t>
-            </a:r>
-          </a:p>
-          <a:p>
-            <a:pPr algn="l">
-              <a:spcAft>
-                <a:spcPts val="1000"/>
-              </a:spcAft>
-            </a:pPr>
-            <a:r>
-              <a:rPr sz="1600" b="0">
-                <a:solidFill>
-                  <a:srgbClr val="222222"/>
-                </a:solidFill>
-                <a:latin typeface="맑은 고딕"/>
-              </a:rPr>
-              <a:t>•  `V$STANDBY_EVENT_HISTOGRAM` 은 `apply lag` 하나만 누적한다. 2분 정지가 `2 minutes` 59회로 남았다.</a:t>
+              <a:t>•  그래서 `V$DATAGUARD_STATS` 는 **닫혀 있어도 값이 나온다**</a:t>
             </a:r>
           </a:p>
         </p:txBody>
@@ -11887,7 +11864,7 @@
                 </a:solidFill>
                 <a:latin typeface="맑은 고딕"/>
               </a:rPr>
-              <a:t>실습 개요 (Practice Overview)</a:t>
+              <a:t>Primary 에서 읽는 두 열</a:t>
             </a:r>
           </a:p>
         </p:txBody>
@@ -11900,8 +11877,8 @@
         </p:nvSpPr>
         <p:spPr>
           <a:xfrm>
-            <a:off x="640080" y="1371600"/>
-            <a:ext cx="10881360" cy="5120640"/>
+            <a:off x="640080" y="1078992"/>
+            <a:ext cx="10881360" cy="457200"/>
           </a:xfrm>
           <a:prstGeom prst="rect">
             <a:avLst/>
@@ -11916,16 +11893,939 @@
           <a:p>
             <a:pPr algn="l">
               <a:spcAft>
+                <a:spcPts val="600"/>
+              </a:spcAft>
+            </a:pPr>
+            <a:r>
+              <a:rPr sz="1500" b="0">
+                <a:solidFill>
+                  <a:srgbClr val="5A6672"/>
+                </a:solidFill>
+                <a:latin typeface="맑은 고딕"/>
+              </a:rPr>
+              <a:t>WITH QUERY 가 표식이다</a:t>
+            </a:r>
+          </a:p>
+        </p:txBody>
+      </p:sp>
+      <p:sp>
+        <p:nvSpPr>
+          <p:cNvPr id="5" name="TextBox 4"/>
+          <p:cNvSpPr txBox="1"/>
+          <p:nvPr/>
+        </p:nvSpPr>
+        <p:spPr>
+          <a:xfrm>
+            <a:off x="640080" y="1737360"/>
+            <a:ext cx="10881360" cy="4754880"/>
+          </a:xfrm>
+          <a:prstGeom prst="rect">
+            <a:avLst/>
+          </a:prstGeom>
+          <a:noFill/>
+        </p:spPr>
+        <p:txBody>
+          <a:bodyPr wrap="square">
+            <a:spAutoFit/>
+          </a:bodyPr>
+          <a:lstStyle/>
+          <a:p>
+            <a:pPr algn="l">
+              <a:spcAft>
                 <a:spcPts val="1000"/>
               </a:spcAft>
             </a:pPr>
             <a:r>
+              <a:rPr sz="1700" b="0">
+                <a:solidFill>
+                  <a:srgbClr val="222222"/>
+                </a:solidFill>
+                <a:latin typeface="맑은 고딕"/>
+              </a:rPr>
+              <a:t>•  `DATABASE_MODE` — `OPEN_READ-ONLY` ↔ **`MOUNTED-STANDBY`**</a:t>
+            </a:r>
+          </a:p>
+          <a:p>
+            <a:pPr algn="l">
+              <a:spcAft>
+                <a:spcPts val="1000"/>
+              </a:spcAft>
+            </a:pPr>
+            <a:r>
+              <a:rPr sz="1700" b="0">
+                <a:solidFill>
+                  <a:srgbClr val="222222"/>
+                </a:solidFill>
+                <a:latin typeface="맑은 고딕"/>
+              </a:rPr>
+              <a:t>•  `RECOVERY_MODE` — `... REAL TIME APPLY` **`WITH QUERY`** 유무</a:t>
+            </a:r>
+          </a:p>
+          <a:p>
+            <a:pPr algn="l">
+              <a:spcAft>
+                <a:spcPts val="1000"/>
+              </a:spcAft>
+            </a:pPr>
+            <a:r>
+              <a:rPr sz="1700" b="0">
+                <a:solidFill>
+                  <a:srgbClr val="222222"/>
+                </a:solidFill>
+                <a:latin typeface="맑은 고딕"/>
+              </a:rPr>
+              <a:t>•  `APPLIED_SEQ#` 는 닫은 뒤에도 올라간다 (8 → 10)</a:t>
+            </a:r>
+          </a:p>
+          <a:p>
+            <a:pPr algn="l">
+              <a:spcAft>
+                <a:spcPts val="1000"/>
+              </a:spcAft>
+            </a:pPr>
+            <a:r>
+              <a:rPr sz="1700" b="0">
+                <a:solidFill>
+                  <a:srgbClr val="222222"/>
+                </a:solidFill>
+                <a:latin typeface="맑은 고딕"/>
+              </a:rPr>
+              <a:t>•  `V$DATAGUARD_STATS` 는 Primary 에서 **0행** — 이 방법은 성립하지 않는다</a:t>
+            </a:r>
+          </a:p>
+        </p:txBody>
+      </p:sp>
+    </p:spTree>
+  </p:cSld>
+  <p:clrMapOvr>
+    <a:masterClrMapping/>
+  </p:clrMapOvr>
+</p:sld>
+</file>
+
+<file path=ppt/slides/slide36.xml><?xml version="1.0" encoding="utf-8"?>
+<p:sld xmlns:a="http://schemas.openxmlformats.org/drawingml/2006/main" xmlns:p="http://schemas.openxmlformats.org/presentationml/2006/main" xmlns:r="http://schemas.openxmlformats.org/officeDocument/2006/relationships">
+  <p:cSld>
+    <p:spTree>
+      <p:nvGrpSpPr>
+        <p:cNvPr id="1" name=""/>
+        <p:cNvGrpSpPr/>
+        <p:nvPr/>
+      </p:nvGrpSpPr>
+      <p:grpSpPr/>
+      <p:sp>
+        <p:nvSpPr>
+          <p:cNvPr id="2" name="Rectangle 1"/>
+          <p:cNvSpPr/>
+          <p:nvPr/>
+        </p:nvSpPr>
+        <p:spPr>
+          <a:xfrm>
+            <a:off x="0" y="0"/>
+            <a:ext cx="12191695" cy="1005840"/>
+          </a:xfrm>
+          <a:prstGeom prst="rect">
+            <a:avLst/>
+          </a:prstGeom>
+          <a:solidFill>
+            <a:srgbClr val="C0392B"/>
+          </a:solidFill>
+          <a:ln>
+            <a:noFill/>
+          </a:ln>
+          <a:effectLst/>
+        </p:spPr>
+        <p:style>
+          <a:lnRef idx="1">
+            <a:schemeClr val="accent1"/>
+          </a:lnRef>
+          <a:fillRef idx="3">
+            <a:schemeClr val="accent1"/>
+          </a:fillRef>
+          <a:effectRef idx="2">
+            <a:schemeClr val="accent1"/>
+          </a:effectRef>
+          <a:fontRef idx="minor">
+            <a:schemeClr val="lt1"/>
+          </a:fontRef>
+        </p:style>
+        <p:txBody>
+          <a:bodyPr rtlCol="0" anchor="ctr"/>
+          <a:lstStyle/>
+          <a:p>
+            <a:pPr algn="ctr"/>
+          </a:p>
+        </p:txBody>
+      </p:sp>
+      <p:sp>
+        <p:nvSpPr>
+          <p:cNvPr id="3" name="TextBox 2"/>
+          <p:cNvSpPr txBox="1"/>
+          <p:nvPr/>
+        </p:nvSpPr>
+        <p:spPr>
+          <a:xfrm>
+            <a:off x="548640" y="91440"/>
+            <a:ext cx="10972800" cy="777240"/>
+          </a:xfrm>
+          <a:prstGeom prst="rect">
+            <a:avLst/>
+          </a:prstGeom>
+          <a:noFill/>
+        </p:spPr>
+        <p:txBody>
+          <a:bodyPr wrap="square">
+            <a:spAutoFit/>
+          </a:bodyPr>
+          <a:lstStyle/>
+          <a:p>
+            <a:pPr algn="l">
+              <a:spcAft>
+                <a:spcPts val="600"/>
+              </a:spcAft>
+            </a:pPr>
+            <a:r>
+              <a:rPr sz="2600" b="1">
+                <a:solidFill>
+                  <a:srgbClr val="FFFFFF"/>
+                </a:solidFill>
+                <a:latin typeface="맑은 고딕"/>
+              </a:rPr>
+              <a:t>퀴즈 (Quiz)</a:t>
+            </a:r>
+          </a:p>
+        </p:txBody>
+      </p:sp>
+      <p:sp>
+        <p:nvSpPr>
+          <p:cNvPr id="4" name="TextBox 3"/>
+          <p:cNvSpPr txBox="1"/>
+          <p:nvPr/>
+        </p:nvSpPr>
+        <p:spPr>
+          <a:xfrm>
+            <a:off x="640080" y="1371600"/>
+            <a:ext cx="10881360" cy="5120640"/>
+          </a:xfrm>
+          <a:prstGeom prst="rect">
+            <a:avLst/>
+          </a:prstGeom>
+          <a:noFill/>
+        </p:spPr>
+        <p:txBody>
+          <a:bodyPr wrap="square">
+            <a:spAutoFit/>
+          </a:bodyPr>
+          <a:lstStyle/>
+          <a:p>
+            <a:pPr algn="l">
+              <a:spcAft>
+                <a:spcPts val="1000"/>
+              </a:spcAft>
+            </a:pPr>
+            <a:r>
               <a:rPr sz="1600" b="0">
                 <a:solidFill>
                   <a:srgbClr val="222222"/>
                 </a:solidFill>
                 <a:latin typeface="맑은 고딕"/>
               </a:rPr>
+              <a:t>•  Q1. Standby 에서 커밋되지 않은 데이터가 보이지 않는 이유를 리두·UNDO 적용과 연결해 설명하라.</a:t>
+            </a:r>
+          </a:p>
+          <a:p>
+            <a:pPr algn="l">
+              <a:spcAft>
+                <a:spcPts val="1000"/>
+              </a:spcAft>
+            </a:pPr>
+            <a:r>
+              <a:rPr sz="1600" b="0">
+                <a:solidFill>
+                  <a:srgbClr val="222222"/>
+                </a:solidFill>
+                <a:latin typeface="맑은 고딕"/>
+              </a:rPr>
+              <a:t>•  Q2. 첫 측정이 잘못된 결론을 낼 뻔한 원인은 무엇이며, 어떻게 바로잡았는가?</a:t>
+            </a:r>
+          </a:p>
+          <a:p>
+            <a:pPr algn="l">
+              <a:spcAft>
+                <a:spcPts val="1000"/>
+              </a:spcAft>
+            </a:pPr>
+            <a:r>
+              <a:rPr sz="1600" b="0">
+                <a:solidFill>
+                  <a:srgbClr val="222222"/>
+                </a:solidFill>
+                <a:latin typeface="맑은 고딕"/>
+              </a:rPr>
+              <a:t>•  Q3. Standby 에서 되는 작업과 안 되는 작업을 가르는 기준은 무엇인가?</a:t>
+            </a:r>
+          </a:p>
+          <a:p>
+            <a:pPr algn="l">
+              <a:spcAft>
+                <a:spcPts val="1000"/>
+              </a:spcAft>
+            </a:pPr>
+            <a:r>
+              <a:rPr sz="1600" b="0">
+                <a:solidFill>
+                  <a:srgbClr val="222222"/>
+                </a:solidFill>
+                <a:latin typeface="맑은 고딕"/>
+              </a:rPr>
+              <a:t>•  Q4. Standby 에서 얻은 시퀀스 값이 Primary 와 연속되지 않는 이유와 실무적 함의는?</a:t>
+            </a:r>
+          </a:p>
+          <a:p>
+            <a:pPr algn="l">
+              <a:spcAft>
+                <a:spcPts val="1000"/>
+              </a:spcAft>
+            </a:pPr>
+            <a:r>
+              <a:rPr sz="1600" b="0">
+                <a:solidFill>
+                  <a:srgbClr val="222222"/>
+                </a:solidFill>
+                <a:latin typeface="맑은 고딕"/>
+              </a:rPr>
+              <a:t>•  Q5. DML 리다이렉션이 `SYS` 로 실패하는 이유와, 그것이 기능 검증에 주는 교훈은?</a:t>
+            </a:r>
+          </a:p>
+          <a:p>
+            <a:pPr algn="l">
+              <a:spcAft>
+                <a:spcPts val="1000"/>
+              </a:spcAft>
+            </a:pPr>
+            <a:r>
+              <a:rPr sz="1600" b="0">
+                <a:solidFill>
+                  <a:srgbClr val="222222"/>
+                </a:solidFill>
+                <a:latin typeface="맑은 고딕"/>
+              </a:rPr>
+              <a:t>•  Q6. ASYNC 구성에서 `SYNC WITH PRIMARY` 가 거부되는 이유를 보호 모드와 연결해 설명하라.</a:t>
+            </a:r>
+          </a:p>
+        </p:txBody>
+      </p:sp>
+    </p:spTree>
+  </p:cSld>
+  <p:clrMapOvr>
+    <a:masterClrMapping/>
+  </p:clrMapOvr>
+</p:sld>
+</file>
+
+<file path=ppt/slides/slide37.xml><?xml version="1.0" encoding="utf-8"?>
+<p:sld xmlns:a="http://schemas.openxmlformats.org/drawingml/2006/main" xmlns:p="http://schemas.openxmlformats.org/presentationml/2006/main" xmlns:r="http://schemas.openxmlformats.org/officeDocument/2006/relationships">
+  <p:cSld>
+    <p:spTree>
+      <p:nvGrpSpPr>
+        <p:cNvPr id="1" name=""/>
+        <p:cNvGrpSpPr/>
+        <p:nvPr/>
+      </p:nvGrpSpPr>
+      <p:grpSpPr/>
+      <p:sp>
+        <p:nvSpPr>
+          <p:cNvPr id="2" name="Rectangle 1"/>
+          <p:cNvSpPr/>
+          <p:nvPr/>
+        </p:nvSpPr>
+        <p:spPr>
+          <a:xfrm>
+            <a:off x="0" y="0"/>
+            <a:ext cx="12191695" cy="1005840"/>
+          </a:xfrm>
+          <a:prstGeom prst="rect">
+            <a:avLst/>
+          </a:prstGeom>
+          <a:solidFill>
+            <a:srgbClr val="C0392B"/>
+          </a:solidFill>
+          <a:ln>
+            <a:noFill/>
+          </a:ln>
+          <a:effectLst/>
+        </p:spPr>
+        <p:style>
+          <a:lnRef idx="1">
+            <a:schemeClr val="accent1"/>
+          </a:lnRef>
+          <a:fillRef idx="3">
+            <a:schemeClr val="accent1"/>
+          </a:fillRef>
+          <a:effectRef idx="2">
+            <a:schemeClr val="accent1"/>
+          </a:effectRef>
+          <a:fontRef idx="minor">
+            <a:schemeClr val="lt1"/>
+          </a:fontRef>
+        </p:style>
+        <p:txBody>
+          <a:bodyPr rtlCol="0" anchor="ctr"/>
+          <a:lstStyle/>
+          <a:p>
+            <a:pPr algn="ctr"/>
+          </a:p>
+        </p:txBody>
+      </p:sp>
+      <p:sp>
+        <p:nvSpPr>
+          <p:cNvPr id="3" name="TextBox 2"/>
+          <p:cNvSpPr txBox="1"/>
+          <p:nvPr/>
+        </p:nvSpPr>
+        <p:spPr>
+          <a:xfrm>
+            <a:off x="548640" y="91440"/>
+            <a:ext cx="10972800" cy="777240"/>
+          </a:xfrm>
+          <a:prstGeom prst="rect">
+            <a:avLst/>
+          </a:prstGeom>
+          <a:noFill/>
+        </p:spPr>
+        <p:txBody>
+          <a:bodyPr wrap="square">
+            <a:spAutoFit/>
+          </a:bodyPr>
+          <a:lstStyle/>
+          <a:p>
+            <a:pPr algn="l">
+              <a:spcAft>
+                <a:spcPts val="600"/>
+              </a:spcAft>
+            </a:pPr>
+            <a:r>
+              <a:rPr sz="2600" b="1">
+                <a:solidFill>
+                  <a:srgbClr val="FFFFFF"/>
+                </a:solidFill>
+                <a:latin typeface="맑은 고딕"/>
+              </a:rPr>
+              <a:t>요약 (Summary)</a:t>
+            </a:r>
+          </a:p>
+        </p:txBody>
+      </p:sp>
+      <p:sp>
+        <p:nvSpPr>
+          <p:cNvPr id="4" name="TextBox 3"/>
+          <p:cNvSpPr txBox="1"/>
+          <p:nvPr/>
+        </p:nvSpPr>
+        <p:spPr>
+          <a:xfrm>
+            <a:off x="640080" y="1371600"/>
+            <a:ext cx="10881360" cy="5120640"/>
+          </a:xfrm>
+          <a:prstGeom prst="rect">
+            <a:avLst/>
+          </a:prstGeom>
+          <a:noFill/>
+        </p:spPr>
+        <p:txBody>
+          <a:bodyPr wrap="square">
+            <a:spAutoFit/>
+          </a:bodyPr>
+          <a:lstStyle/>
+          <a:p>
+            <a:pPr algn="l">
+              <a:spcAft>
+                <a:spcPts val="1000"/>
+              </a:spcAft>
+            </a:pPr>
+            <a:r>
+              <a:rPr sz="1600" b="0">
+                <a:solidFill>
+                  <a:srgbClr val="222222"/>
+                </a:solidFill>
+                <a:latin typeface="맑은 고딕"/>
+              </a:rPr>
+              <a:t>•  ADG 의 표식은 `OPEN_MODE = READ ONLY WITH APPLY` 와 `RECOVERY_MODE = MANAGED REAL TIME APPLY` 두 가지다.</a:t>
+            </a:r>
+          </a:p>
+          <a:p>
+            <a:pPr algn="l">
+              <a:spcAft>
+                <a:spcPts val="1000"/>
+              </a:spcAft>
+            </a:pPr>
+            <a:r>
+              <a:rPr sz="1600" b="0">
+                <a:solidFill>
+                  <a:srgbClr val="222222"/>
+                </a:solidFill>
+                <a:latin typeface="맑은 고딕"/>
+              </a:rPr>
+              <a:t>•  기능 사용 통계는 `CDB_` 뷰의 CON_ID 3 에만 있고 `DETECTED_USAGES` 는 0이었다. 라이선스 근거로는 부족하다.</a:t>
+            </a:r>
+          </a:p>
+          <a:p>
+            <a:pPr algn="l">
+              <a:spcAft>
+                <a:spcPts val="1000"/>
+              </a:spcAft>
+            </a:pPr>
+            <a:r>
+              <a:rPr sz="1600" b="0">
+                <a:solidFill>
+                  <a:srgbClr val="222222"/>
+                </a:solidFill>
+                <a:latin typeface="맑은 고딕"/>
+              </a:rPr>
+              <a:t>•  MOUNTED 로만 두면 ADG 옵션이 필요 없다. 여는 순간부터 옵션의 영역이다.</a:t>
+            </a:r>
+          </a:p>
+          <a:p>
+            <a:pPr algn="l">
+              <a:spcAft>
+                <a:spcPts val="1000"/>
+              </a:spcAft>
+            </a:pPr>
+            <a:r>
+              <a:rPr sz="1600" b="0">
+                <a:solidFill>
+                  <a:srgbClr val="222222"/>
+                </a:solidFill>
+                <a:latin typeface="맑은 고딕"/>
+              </a:rPr>
+              <a:t>•  Standby 조회는 **커밋된 데이터만** 보여 준다. 리두와 함께 UNDO 도 적용되기 때문이다.</a:t>
+            </a:r>
+          </a:p>
+          <a:p>
+            <a:pPr algn="l">
+              <a:spcAft>
+                <a:spcPts val="1000"/>
+              </a:spcAft>
+            </a:pPr>
+            <a:r>
+              <a:rPr sz="1600" b="0">
+                <a:solidFill>
+                  <a:srgbClr val="222222"/>
+                </a:solidFill>
+                <a:latin typeface="맑은 고딕"/>
+              </a:rPr>
+              <a:t>•  SQL*Plus 는 `EXIT` 시 암묵적으로 커밋한다. 이 때문에 첫 측정이 잘못된 결론을 낼 뻔했다.</a:t>
+            </a:r>
+          </a:p>
+          <a:p>
+            <a:pPr algn="l">
+              <a:spcAft>
+                <a:spcPts val="1000"/>
+              </a:spcAft>
+            </a:pPr>
+            <a:r>
+              <a:rPr sz="1600" b="0">
+                <a:solidFill>
+                  <a:srgbClr val="222222"/>
+                </a:solidFill>
+                <a:latin typeface="맑은 고딕"/>
+              </a:rPr>
+              <a:t>•  쓰기는 모두 **ORA-16000** 이다. `INSERT`·`UPDATE`·DDL 이 같은 오류다.</a:t>
+            </a:r>
+          </a:p>
+          <a:p>
+            <a:pPr algn="l">
+              <a:spcAft>
+                <a:spcPts val="1000"/>
+              </a:spcAft>
+            </a:pPr>
+            <a:r>
+              <a:rPr sz="1600" b="0">
+                <a:solidFill>
+                  <a:srgbClr val="222222"/>
+                </a:solidFill>
+                <a:latin typeface="맑은 고딕"/>
+              </a:rPr>
+              <a:t>•  정렬은 된다. 실측 7만 행 정렬에 TEMP 3MB 씩 사용됐다. 보고서 조회를 옮기는 근거다.</a:t>
+            </a:r>
+          </a:p>
+          <a:p>
+            <a:pPr algn="l">
+              <a:spcAft>
+                <a:spcPts val="1000"/>
+              </a:spcAft>
+            </a:pPr>
+            <a:r>
+              <a:rPr sz="1600" b="0">
+                <a:solidFill>
+                  <a:srgbClr val="222222"/>
+                </a:solidFill>
+                <a:latin typeface="맑은 고딕"/>
+              </a:rPr>
+              <a:t>•  `EXPLAIN PLAN` 과 GTT `INSERT` 도 된다. 데이터가 임시 테이블스페이스에 있기 때문이다.</a:t>
+            </a:r>
+          </a:p>
+          <a:p>
+            <a:pPr algn="l">
+              <a:spcAft>
+                <a:spcPts val="1000"/>
+              </a:spcAft>
+            </a:pPr>
+            <a:r>
+              <a:rPr sz="1600" b="0">
+                <a:solidFill>
+                  <a:srgbClr val="222222"/>
+                </a:solidFill>
+                <a:latin typeface="맑은 고딕"/>
+              </a:rPr>
+              <a:t>•  시퀀스도 되지만 **값이 뛴다.** Primary 에서 1이었던 시퀀스가 Standby 에서 21을 돌려주었다.</a:t>
+            </a:r>
+          </a:p>
+          <a:p>
+            <a:pPr algn="l">
+              <a:spcAft>
+                <a:spcPts val="1000"/>
+              </a:spcAft>
+            </a:pPr>
+            <a:r>
+              <a:rPr sz="1600" b="0">
+                <a:solidFill>
+                  <a:srgbClr val="222222"/>
+                </a:solidFill>
+                <a:latin typeface="맑은 고딕"/>
+              </a:rPr>
+              <a:t>•  통계 수집은 ORA-16000, AWR 은 전용 오류 **ORA-13516**. `V$` 뷰 조회는 자유롭다.</a:t>
+            </a:r>
+          </a:p>
+          <a:p>
+            <a:pPr algn="l">
+              <a:spcAft>
+                <a:spcPts val="1000"/>
+              </a:spcAft>
+            </a:pPr>
+            <a:r>
+              <a:rPr sz="1600" b="0">
+                <a:solidFill>
+                  <a:srgbClr val="222222"/>
+                </a:solidFill>
+                <a:latin typeface="맑은 고딕"/>
+              </a:rPr>
+              <a:t>•  경계를 가르는 기준은 **영구 데이터 파일이나 딕셔너리를 바꾸는가** 하나다.</a:t>
+            </a:r>
+          </a:p>
+          <a:p>
+            <a:pPr algn="l">
+              <a:spcAft>
+                <a:spcPts val="1000"/>
+              </a:spcAft>
+            </a:pPr>
+            <a:r>
+              <a:rPr sz="1600" b="0">
+                <a:solidFill>
+                  <a:srgbClr val="222222"/>
+                </a:solidFill>
+                <a:latin typeface="맑은 고딕"/>
+              </a:rPr>
+              <a:t>•  DML 리다이렉션은 일반 사용자로 `INSERT`·`UPDATE`·`DELETE` 가 모두 성공하며 Primary 에 반영된다.</a:t>
+            </a:r>
+          </a:p>
+          <a:p>
+            <a:pPr algn="l">
+              <a:spcAft>
+                <a:spcPts val="1000"/>
+              </a:spcAft>
+            </a:pPr>
+            <a:r>
+              <a:rPr sz="1600" b="0">
+                <a:solidFill>
+                  <a:srgbClr val="222222"/>
+                </a:solidFill>
+                <a:latin typeface="맑은 고딕"/>
+              </a:rPr>
+              <a:t>•  **`SYS` 로는 ORA-16397 로 실패한다.** 관리자 계정으로 시험하면 기능이 없다고 오판하기 쉽다.</a:t>
+            </a:r>
+          </a:p>
+          <a:p>
+            <a:pPr algn="l">
+              <a:spcAft>
+                <a:spcPts val="1000"/>
+              </a:spcAft>
+            </a:pPr>
+            <a:r>
+              <a:rPr sz="1600" b="0">
+                <a:solidFill>
+                  <a:srgbClr val="222222"/>
+                </a:solidFill>
+                <a:latin typeface="맑은 고딕"/>
+              </a:rPr>
+              <a:t>•  DDL 은 대상이 아니다. ORA-16000 이 나며, 오류 번호가 처리 경로를 알려 준다.</a:t>
+            </a:r>
+          </a:p>
+          <a:p>
+            <a:pPr algn="l">
+              <a:spcAft>
+                <a:spcPts val="1000"/>
+              </a:spcAft>
+            </a:pPr>
+            <a:r>
+              <a:rPr sz="1600" b="0">
+                <a:solidFill>
+                  <a:srgbClr val="222222"/>
+                </a:solidFill>
+                <a:latin typeface="맑은 고딕"/>
+              </a:rPr>
+              <a:t>•  리다이렉션의 가치는 부하 분산이 아니라 **접속 단순화**다. 실행은 Primary 에서 일어난다.</a:t>
+            </a:r>
+          </a:p>
+          <a:p>
+            <a:pPr algn="l">
+              <a:spcAft>
+                <a:spcPts val="1000"/>
+              </a:spcAft>
+            </a:pPr>
+            <a:r>
+              <a:rPr sz="1600" b="0">
+                <a:solidFill>
+                  <a:srgbClr val="222222"/>
+                </a:solidFill>
+                <a:latin typeface="맑은 고딕"/>
+              </a:rPr>
+              <a:t>•  `STANDBY_MAX_DATA_DELAY` 초과 시 **ORA-03172**. ASYNC 에서 0은 항상 위반된다.</a:t>
+            </a:r>
+          </a:p>
+          <a:p>
+            <a:pPr algn="l">
+              <a:spcAft>
+                <a:spcPts val="1000"/>
+              </a:spcAft>
+            </a:pPr>
+            <a:r>
+              <a:rPr sz="1600" b="0">
+                <a:solidFill>
+                  <a:srgbClr val="222222"/>
+                </a:solidFill>
+                <a:latin typeface="맑은 고딕"/>
+              </a:rPr>
+              <a:t>•  **`SYS` 세션에는 적용되지 않는다 — ORA-03174.** ADG 세션 기능은 일반 사용자를 전제로 한다.</a:t>
+            </a:r>
+          </a:p>
+          <a:p>
+            <a:pPr algn="l">
+              <a:spcAft>
+                <a:spcPts val="1000"/>
+              </a:spcAft>
+            </a:pPr>
+            <a:r>
+              <a:rPr sz="1600" b="0">
+                <a:solidFill>
+                  <a:srgbClr val="222222"/>
+                </a:solidFill>
+                <a:latin typeface="맑은 고딕"/>
+              </a:rPr>
+              <a:t>•  `SYNC WITH PRIMARY` 는 동기 전송이 전제다. ASYNC 에서는 **ORA-03173**.</a:t>
+            </a:r>
+          </a:p>
+          <a:p>
+            <a:pPr algn="l">
+              <a:spcAft>
+                <a:spcPts val="1000"/>
+              </a:spcAft>
+            </a:pPr>
+            <a:r>
+              <a:rPr sz="1600" b="0">
+                <a:solidFill>
+                  <a:srgbClr val="222222"/>
+                </a:solidFill>
+                <a:latin typeface="맑은 고딕"/>
+              </a:rPr>
+              <a:t>•  보호 모드는 8장에서 복구 가능성을, 9장에서 조회 신선도 보장을 결정했다.</a:t>
+            </a:r>
+          </a:p>
+          <a:p>
+            <a:pPr algn="l">
+              <a:spcAft>
+                <a:spcPts val="1000"/>
+              </a:spcAft>
+            </a:pPr>
+            <a:r>
+              <a:rPr sz="1600" b="0">
+                <a:solidFill>
+                  <a:srgbClr val="222222"/>
+                </a:solidFill>
+                <a:latin typeface="맑은 고딕"/>
+              </a:rPr>
+              <a:t>•  `V$STANDBY_EVENT_HISTOGRAM` 은 `apply lag` 하나만 누적한다. 2분 정지가 `2 minutes` 59회로 남았다.</a:t>
+            </a:r>
+          </a:p>
+          <a:p>
+            <a:pPr algn="l">
+              <a:spcAft>
+                <a:spcPts val="1000"/>
+              </a:spcAft>
+            </a:pPr>
+            <a:r>
+              <a:rPr sz="1600" b="0">
+                <a:solidFill>
+                  <a:srgbClr val="222222"/>
+                </a:solidFill>
+                <a:latin typeface="맑은 고딕"/>
+              </a:rPr>
+              <a:t>•  옵션 없이 쓰려면 MOUNTED 로 둔다. 적용은 돌고 조회만 **ORA-01219** 로 막힌다.</a:t>
+            </a:r>
+          </a:p>
+          <a:p>
+            <a:pPr algn="l">
+              <a:spcAft>
+                <a:spcPts val="1000"/>
+              </a:spcAft>
+            </a:pPr>
+            <a:r>
+              <a:rPr sz="1600" b="0">
+                <a:solidFill>
+                  <a:srgbClr val="222222"/>
+                </a:solidFill>
+                <a:latin typeface="맑은 고딕"/>
+              </a:rPr>
+              <a:t>•  Primary 쪽 표식은 `DATABASE_MODE` 와 `RECOVERY_MODE` 의 **`WITH QUERY`** 유무다.</a:t>
+            </a:r>
+          </a:p>
+        </p:txBody>
+      </p:sp>
+    </p:spTree>
+  </p:cSld>
+  <p:clrMapOvr>
+    <a:masterClrMapping/>
+  </p:clrMapOvr>
+</p:sld>
+</file>
+
+<file path=ppt/slides/slide38.xml><?xml version="1.0" encoding="utf-8"?>
+<p:sld xmlns:a="http://schemas.openxmlformats.org/drawingml/2006/main" xmlns:p="http://schemas.openxmlformats.org/presentationml/2006/main" xmlns:r="http://schemas.openxmlformats.org/officeDocument/2006/relationships">
+  <p:cSld>
+    <p:spTree>
+      <p:nvGrpSpPr>
+        <p:cNvPr id="1" name=""/>
+        <p:cNvGrpSpPr/>
+        <p:nvPr/>
+      </p:nvGrpSpPr>
+      <p:grpSpPr/>
+      <p:sp>
+        <p:nvSpPr>
+          <p:cNvPr id="2" name="Rectangle 1"/>
+          <p:cNvSpPr/>
+          <p:nvPr/>
+        </p:nvSpPr>
+        <p:spPr>
+          <a:xfrm>
+            <a:off x="0" y="0"/>
+            <a:ext cx="12191695" cy="1005840"/>
+          </a:xfrm>
+          <a:prstGeom prst="rect">
+            <a:avLst/>
+          </a:prstGeom>
+          <a:solidFill>
+            <a:srgbClr val="C0392B"/>
+          </a:solidFill>
+          <a:ln>
+            <a:noFill/>
+          </a:ln>
+          <a:effectLst/>
+        </p:spPr>
+        <p:style>
+          <a:lnRef idx="1">
+            <a:schemeClr val="accent1"/>
+          </a:lnRef>
+          <a:fillRef idx="3">
+            <a:schemeClr val="accent1"/>
+          </a:fillRef>
+          <a:effectRef idx="2">
+            <a:schemeClr val="accent1"/>
+          </a:effectRef>
+          <a:fontRef idx="minor">
+            <a:schemeClr val="lt1"/>
+          </a:fontRef>
+        </p:style>
+        <p:txBody>
+          <a:bodyPr rtlCol="0" anchor="ctr"/>
+          <a:lstStyle/>
+          <a:p>
+            <a:pPr algn="ctr"/>
+          </a:p>
+        </p:txBody>
+      </p:sp>
+      <p:sp>
+        <p:nvSpPr>
+          <p:cNvPr id="3" name="TextBox 2"/>
+          <p:cNvSpPr txBox="1"/>
+          <p:nvPr/>
+        </p:nvSpPr>
+        <p:spPr>
+          <a:xfrm>
+            <a:off x="548640" y="91440"/>
+            <a:ext cx="10972800" cy="777240"/>
+          </a:xfrm>
+          <a:prstGeom prst="rect">
+            <a:avLst/>
+          </a:prstGeom>
+          <a:noFill/>
+        </p:spPr>
+        <p:txBody>
+          <a:bodyPr wrap="square">
+            <a:spAutoFit/>
+          </a:bodyPr>
+          <a:lstStyle/>
+          <a:p>
+            <a:pPr algn="l">
+              <a:spcAft>
+                <a:spcPts val="600"/>
+              </a:spcAft>
+            </a:pPr>
+            <a:r>
+              <a:rPr sz="2600" b="1">
+                <a:solidFill>
+                  <a:srgbClr val="FFFFFF"/>
+                </a:solidFill>
+                <a:latin typeface="맑은 고딕"/>
+              </a:rPr>
+              <a:t>실습 개요 (Practice Overview)</a:t>
+            </a:r>
+          </a:p>
+        </p:txBody>
+      </p:sp>
+      <p:sp>
+        <p:nvSpPr>
+          <p:cNvPr id="4" name="TextBox 3"/>
+          <p:cNvSpPr txBox="1"/>
+          <p:nvPr/>
+        </p:nvSpPr>
+        <p:spPr>
+          <a:xfrm>
+            <a:off x="640080" y="1371600"/>
+            <a:ext cx="10881360" cy="5120640"/>
+          </a:xfrm>
+          <a:prstGeom prst="rect">
+            <a:avLst/>
+          </a:prstGeom>
+          <a:noFill/>
+        </p:spPr>
+        <p:txBody>
+          <a:bodyPr wrap="square">
+            <a:spAutoFit/>
+          </a:bodyPr>
+          <a:lstStyle/>
+          <a:p>
+            <a:pPr algn="l">
+              <a:spcAft>
+                <a:spcPts val="1000"/>
+              </a:spcAft>
+            </a:pPr>
+            <a:r>
+              <a:rPr sz="1600" b="0">
+                <a:solidFill>
+                  <a:srgbClr val="222222"/>
+                </a:solidFill>
+                <a:latin typeface="맑은 고딕"/>
+              </a:rPr>
               <a:t>•  실습 01 — ADG 상태 확인: 두 표식과 기능 사용 통계, 세션 컨텍스트, PDB 서비스를 확인한다.</a:t>
             </a:r>
           </a:p>
@@ -12038,7 +12938,23 @@
                 </a:solidFill>
                 <a:latin typeface="맑은 고딕"/>
               </a:rPr>
-              <a:t>•  실습 06·07 은 적용을 멈춘다. 각 실습 끝에서 반드시 원복한다.</a:t>
+              <a:t>•  실습 08 — 옵션 없는 대안 경로: MOUNTED 로 내려 `ORA-01219` 를 재현하고 양쪽에서 동기화를 확인한다.</a:t>
+            </a:r>
+          </a:p>
+          <a:p>
+            <a:pPr algn="l">
+              <a:spcAft>
+                <a:spcPts val="1000"/>
+              </a:spcAft>
+            </a:pPr>
+            <a:r>
+              <a:rPr sz="1600" b="0">
+                <a:solidFill>
+                  <a:srgbClr val="222222"/>
+                </a:solidFill>
+                <a:latin typeface="맑은 고딕"/>
+              </a:rPr>
+              <a:t>•  실습 06·07 은 적용을 멈추고 08 은 Standby 를 닫는다. 각 실습 끝에서 반드시 원복한다.</a:t>
             </a:r>
           </a:p>
         </p:txBody>

</xml_diff>